<commit_message>
Finalized presentations for lectures 2-6
</commit_message>
<xml_diff>
--- a/ECE1390_Lecture3.pptx
+++ b/ECE1390_Lecture3.pptx
@@ -271,7 +271,7 @@
           <a:p>
             <a:fld id="{13E9B49C-C8FD-4344-8CD3-ED4C91409D68}" type="datetimeFigureOut">
               <a:rPr lang="en-US" smtClean="0"/>
-              <a:t>8/14/24</a:t>
+              <a:t>8/24/24</a:t>
             </a:fld>
             <a:endParaRPr lang="en-US"/>
           </a:p>
@@ -469,7 +469,7 @@
           <a:p>
             <a:fld id="{13E9B49C-C8FD-4344-8CD3-ED4C91409D68}" type="datetimeFigureOut">
               <a:rPr lang="en-US" smtClean="0"/>
-              <a:t>8/14/24</a:t>
+              <a:t>8/24/24</a:t>
             </a:fld>
             <a:endParaRPr lang="en-US"/>
           </a:p>
@@ -677,7 +677,7 @@
           <a:p>
             <a:fld id="{13E9B49C-C8FD-4344-8CD3-ED4C91409D68}" type="datetimeFigureOut">
               <a:rPr lang="en-US" smtClean="0"/>
-              <a:t>8/14/24</a:t>
+              <a:t>8/24/24</a:t>
             </a:fld>
             <a:endParaRPr lang="en-US"/>
           </a:p>
@@ -875,7 +875,7 @@
           <a:p>
             <a:fld id="{13E9B49C-C8FD-4344-8CD3-ED4C91409D68}" type="datetimeFigureOut">
               <a:rPr lang="en-US" smtClean="0"/>
-              <a:t>8/14/24</a:t>
+              <a:t>8/24/24</a:t>
             </a:fld>
             <a:endParaRPr lang="en-US"/>
           </a:p>
@@ -1150,7 +1150,7 @@
           <a:p>
             <a:fld id="{13E9B49C-C8FD-4344-8CD3-ED4C91409D68}" type="datetimeFigureOut">
               <a:rPr lang="en-US" smtClean="0"/>
-              <a:t>8/14/24</a:t>
+              <a:t>8/24/24</a:t>
             </a:fld>
             <a:endParaRPr lang="en-US"/>
           </a:p>
@@ -1415,7 +1415,7 @@
           <a:p>
             <a:fld id="{13E9B49C-C8FD-4344-8CD3-ED4C91409D68}" type="datetimeFigureOut">
               <a:rPr lang="en-US" smtClean="0"/>
-              <a:t>8/14/24</a:t>
+              <a:t>8/24/24</a:t>
             </a:fld>
             <a:endParaRPr lang="en-US"/>
           </a:p>
@@ -1827,7 +1827,7 @@
           <a:p>
             <a:fld id="{13E9B49C-C8FD-4344-8CD3-ED4C91409D68}" type="datetimeFigureOut">
               <a:rPr lang="en-US" smtClean="0"/>
-              <a:t>8/14/24</a:t>
+              <a:t>8/24/24</a:t>
             </a:fld>
             <a:endParaRPr lang="en-US"/>
           </a:p>
@@ -1968,7 +1968,7 @@
           <a:p>
             <a:fld id="{13E9B49C-C8FD-4344-8CD3-ED4C91409D68}" type="datetimeFigureOut">
               <a:rPr lang="en-US" smtClean="0"/>
-              <a:t>8/14/24</a:t>
+              <a:t>8/24/24</a:t>
             </a:fld>
             <a:endParaRPr lang="en-US"/>
           </a:p>
@@ -2081,7 +2081,7 @@
           <a:p>
             <a:fld id="{13E9B49C-C8FD-4344-8CD3-ED4C91409D68}" type="datetimeFigureOut">
               <a:rPr lang="en-US" smtClean="0"/>
-              <a:t>8/14/24</a:t>
+              <a:t>8/24/24</a:t>
             </a:fld>
             <a:endParaRPr lang="en-US"/>
           </a:p>
@@ -2392,7 +2392,7 @@
           <a:p>
             <a:fld id="{13E9B49C-C8FD-4344-8CD3-ED4C91409D68}" type="datetimeFigureOut">
               <a:rPr lang="en-US" smtClean="0"/>
-              <a:t>8/14/24</a:t>
+              <a:t>8/24/24</a:t>
             </a:fld>
             <a:endParaRPr lang="en-US"/>
           </a:p>
@@ -2680,7 +2680,7 @@
           <a:p>
             <a:fld id="{13E9B49C-C8FD-4344-8CD3-ED4C91409D68}" type="datetimeFigureOut">
               <a:rPr lang="en-US" smtClean="0"/>
-              <a:t>8/14/24</a:t>
+              <a:t>8/24/24</a:t>
             </a:fld>
             <a:endParaRPr lang="en-US"/>
           </a:p>
@@ -2921,7 +2921,7 @@
           <a:p>
             <a:fld id="{13E9B49C-C8FD-4344-8CD3-ED4C91409D68}" type="datetimeFigureOut">
               <a:rPr lang="en-US" smtClean="0"/>
-              <a:t>8/14/24</a:t>
+              <a:t>8/24/24</a:t>
             </a:fld>
             <a:endParaRPr lang="en-US"/>
           </a:p>
@@ -3669,6 +3669,36 @@
           </a:p>
         </p:txBody>
       </p:sp>
+      <p:pic>
+        <p:nvPicPr>
+          <p:cNvPr id="5" name="Picture 4">
+            <a:extLst>
+              <a:ext uri="{FF2B5EF4-FFF2-40B4-BE49-F238E27FC236}">
+                <a16:creationId xmlns:a16="http://schemas.microsoft.com/office/drawing/2014/main" id="{781639AE-D331-7965-55C6-424320D52380}"/>
+              </a:ext>
+            </a:extLst>
+          </p:cNvPr>
+          <p:cNvPicPr>
+            <a:picLocks noChangeAspect="1"/>
+          </p:cNvPicPr>
+          <p:nvPr/>
+        </p:nvPicPr>
+        <p:blipFill>
+          <a:blip r:embed="rId2"/>
+          <a:stretch>
+            <a:fillRect/>
+          </a:stretch>
+        </p:blipFill>
+        <p:spPr>
+          <a:xfrm>
+            <a:off x="4349749" y="3227146"/>
+            <a:ext cx="3981451" cy="3368920"/>
+          </a:xfrm>
+          <a:prstGeom prst="rect">
+            <a:avLst/>
+          </a:prstGeom>
+        </p:spPr>
+      </p:pic>
     </p:spTree>
     <p:extLst>
       <p:ext uri="{BB962C8B-B14F-4D97-AF65-F5344CB8AC3E}">

</xml_diff>